<commit_message>
Remove notebook reference from the pay-by-age chart heading
Co-Authored-By: Claude Opus 5.5 <noreply@anthropic.com>
Claude-Session: https://claude.ai/code/session_01BUoUyCS6UFoobLn1DAhQTP
</commit_message>
<xml_diff>
--- a/presentation/Developer_Technology_Trends_Vincenzo_Ambrosino.pptx
+++ b/presentation/Developer_Technology_Trends_Vincenzo_Ambrosino.pptx
@@ -131,7 +131,7 @@
   <p:extLst>
     <p:ext uri="{521415D9-36F7-43E2-AB2F-B90AF26B5E84}">
       <p14:sectionLst xmlns:p14="http://schemas.microsoft.com/office/powerpoint/2010/main">
-        <p14:section name="Introduction" id="{62393cf6-ff16-024b-d4f7-6f077fb48e5f}">
+        <p14:section name="Introduction" id="{68f41ea0-ef03-110c-dbf6-a0f5990e07e4}">
           <p14:sldIdLst>
             <p14:sldId id="256"/>
             <p14:sldId id="257"/>
@@ -141,7 +141,7 @@
             <p14:sldId id="261"/>
           </p14:sldIdLst>
         </p14:section>
-        <p14:section name="Results" id="{6ff99920-06cb-a977-c851-e26b230c9c61}">
+        <p14:section name="Results" id="{452ad6ac-82dc-7458-710f-97fbe6c6aa33}">
           <p14:sldIdLst>
             <p14:sldId id="262"/>
             <p14:sldId id="263"/>
@@ -152,7 +152,7 @@
             <p14:sldId id="268"/>
           </p14:sldIdLst>
         </p14:section>
-        <p14:section name="Dashboard" id="{abce5039-83f3-af85-cb2a-28cc5a977e2f}">
+        <p14:section name="Dashboard" id="{f34bc6cd-fbd2-ff6f-41c4-addc68671280}">
           <p14:sldIdLst>
             <p14:sldId id="269"/>
             <p14:sldId id="270"/>
@@ -160,7 +160,7 @@
             <p14:sldId id="272"/>
           </p14:sldIdLst>
         </p14:section>
-        <p14:section name="Discussion" id="{0deb839f-6cc6-ba62-8770-2ab6c69620f4}">
+        <p14:section name="Discussion" id="{36be909b-c064-4898-810e-01f249e31587}">
           <p14:sldIdLst>
             <p14:sldId id="273"/>
             <p14:sldId id="274"/>
@@ -168,7 +168,7 @@
             <p14:sldId id="276"/>
           </p14:sldIdLst>
         </p14:section>
-        <p14:section name="Appendix" id="{cd292858-e661-c8d6-8a7f-217fad453c94}">
+        <p14:section name="Appendix" id="{0be861a3-4d19-d0d1-2cfb-c6fd617b6ed3}">
           <p14:sldIdLst>
             <p14:sldId id="277"/>
             <p14:sldId id="278"/>
@@ -21185,7 +21185,7 @@
                   <a:srgbClr val="CBD5E1"/>
                 </a:solidFill>
               </a:rPr>
-              <a:t>Median yearly compensation (USD) by age group · Python (pandas), notebooks 16-17</a:t>
+              <a:t>Median yearly compensation (USD) by age group</a:t>
             </a:r>
             <a:endParaRPr lang="en-US" sz="1400" dirty="0"/>
           </a:p>

</xml_diff>